<commit_message>
office: make the final landing slide point clearly to GitHub
</commit_message>
<xml_diff>
--- a/ui/openoffice/slides/landing-tall.pptx
+++ b/ui/openoffice/slides/landing-tall.pptx
@@ -8025,6 +8025,63 @@
         </p:nvSpPr>
         <p:spPr>
           <a:xfrm>
+            <a:off x="406400" y="6273800"/>
+            <a:ext cx="4902200" cy="2870200"/>
+          </a:xfrm>
+          <a:prstGeom prst="rect">
+            <a:avLst/>
+          </a:prstGeom>
+          <a:noFill/>
+          <a:ln>
+            <a:noFill/>
+          </a:ln>
+        </p:spPr>
+        <p:txBody>
+          <a:bodyPr wrap="square" lIns="0" tIns="0" rIns="0" bIns="0" anchor="t" rtlCol="0">
+            <a:spAutoFit/>
+          </a:bodyPr>
+          <a:lstStyle/>
+          <a:p>
+            <a:pPr algn="l" marL="0" indent="0">
+              <a:lnSpc>
+                <a:spcPct val="100000"/>
+              </a:lnSpc>
+              <a:spcBef>
+                <a:spcPts val="0"/>
+              </a:spcBef>
+              <a:spcAft>
+                <a:spcPts val="0"/>
+              </a:spcAft>
+              <a:buNone/>
+            </a:pPr>
+            <a:r>
+              <a:rPr lang="en-US" sz="1800" b="1" i="0" u="none" strike="noStrike" dirty="0">
+                <a:solidFill>
+                  <a:srgbClr val="FFFFFF"/>
+                </a:solidFill>
+                <a:latin typeface="Calibri"/>
+                <a:cs typeface="Calibri"/>
+              </a:rPr>
+              <a:t>github.com/starling-build/starling</a:t>
+            </a:r>
+            <a:endParaRPr lang="en-US" sz="1800" b="1" i="0" u="none" strike="noStrike" dirty="0">
+              <a:solidFill>
+                <a:srgbClr val="FFFFFF"/>
+              </a:solidFill>
+              <a:latin typeface="Calibri"/>
+              <a:cs typeface="Calibri"/>
+            </a:endParaRPr>
+          </a:p>
+        </p:txBody>
+      </p:sp>
+      <p:sp>
+        <p:nvSpPr>
+          <p:cNvPr id="6" name="TextBox 106"/>
+          <p:cNvSpPr txBox="1"/>
+          <p:nvPr/>
+        </p:nvSpPr>
+        <p:spPr>
+          <a:xfrm>
             <a:off x="406400" y="6832600"/>
             <a:ext cx="4902200" cy="2311400"/>
           </a:xfrm>
@@ -8107,7 +8164,7 @@
       </p:sp>
       <p:sp>
         <p:nvSpPr>
-          <p:cNvPr id="6" name="TextBox 106"/>
+          <p:cNvPr id="7" name="TextBox 107"/>
           <p:cNvSpPr txBox="1"/>
           <p:nvPr/>
         </p:nvSpPr>

</xml_diff>